<commit_message>
Add QR code to last slide linking to GitHub repository
</commit_message>
<xml_diff>
--- a/Copilot-Studio-Presentation.pptx
+++ b/Copilot-Studio-Presentation.pptx
@@ -2313,8 +2313,8 @@
         </p:nvSpPr>
         <p:spPr>
           <a:xfrm>
-            <a:off x="2286000" y="2834640"/>
-            <a:ext cx="4572000" cy="1005840"/>
+            <a:off x="457200" y="2926080"/>
+            <a:ext cx="4114800" cy="1645920"/>
           </a:xfrm>
           <a:prstGeom prst="rect">
             <a:avLst/>
@@ -2345,8 +2345,8 @@
         </p:nvSpPr>
         <p:spPr>
           <a:xfrm>
-            <a:off x="2286000" y="2926080"/>
-            <a:ext cx="4572000" cy="365760"/>
+            <a:off x="640080" y="3063240"/>
+            <a:ext cx="3749040" cy="365760"/>
           </a:xfrm>
           <a:prstGeom prst="rect">
             <a:avLst/>
@@ -2362,7 +2362,7 @@
               <a:buNone/>
             </a:pPr>
             <a:r>
-              <a:rPr lang="en-US" sz="2000" b="1" dirty="0">
+              <a:rPr lang="en-US" sz="1800" b="1" dirty="0">
                 <a:solidFill>
                   <a:srgbClr val="00D9FF"/>
                 </a:solidFill>
@@ -2372,7 +2372,7 @@
               </a:rPr>
               <a:t>🚀 View Online</a:t>
             </a:r>
-            <a:endParaRPr lang="en-US" sz="2000" dirty="0"/>
+            <a:endParaRPr lang="en-US" sz="1800" dirty="0"/>
           </a:p>
         </p:txBody>
       </p:sp>
@@ -2384,8 +2384,8 @@
         </p:nvSpPr>
         <p:spPr>
           <a:xfrm>
-            <a:off x="2286000" y="3337560"/>
-            <a:ext cx="4572000" cy="411480"/>
+            <a:off x="640080" y="3520440"/>
+            <a:ext cx="3749040" cy="914400"/>
           </a:xfrm>
           <a:prstGeom prst="rect">
             <a:avLst/>
@@ -2401,7 +2401,7 @@
               <a:buNone/>
             </a:pPr>
             <a:r>
-              <a:rPr lang="en-US" sz="1200" dirty="0">
+              <a:rPr lang="en-US" sz="1100" dirty="0">
                 <a:solidFill>
                   <a:srgbClr val="FFFFFF"/>
                 </a:solidFill>
@@ -2409,12 +2409,92 @@
                 <a:ea typeface="Calibri" pitchFamily="34" charset="-122"/>
                 <a:cs typeface="Calibri" pitchFamily="34" charset="-120"/>
               </a:rPr>
-              <a:t>https://Mikeyusic.github.io/Copilot-Studio/presentation.html</a:t>
-            </a:r>
-            <a:endParaRPr lang="en-US" sz="1200" dirty="0"/>
-          </a:p>
-        </p:txBody>
-      </p:sp>
+              <a:t>https://Mikeyusic.github.io/</a:t>
+            </a:r>
+            <a:endParaRPr lang="en-US" sz="1100" dirty="0"/>
+          </a:p>
+          <a:p>
+            <a:pPr algn="ctr" indent="0" marL="0">
+              <a:buNone/>
+            </a:pPr>
+            <a:r>
+              <a:rPr lang="en-US" sz="1100" dirty="0">
+                <a:solidFill>
+                  <a:srgbClr val="FFFFFF"/>
+                </a:solidFill>
+                <a:latin typeface="Calibri" pitchFamily="34" charset="0"/>
+                <a:ea typeface="Calibri" pitchFamily="34" charset="-122"/>
+                <a:cs typeface="Calibri" pitchFamily="34" charset="-120"/>
+              </a:rPr>
+              <a:t>Copilot-Studio/presentation.html</a:t>
+            </a:r>
+            <a:endParaRPr lang="en-US" sz="1100" dirty="0"/>
+          </a:p>
+        </p:txBody>
+      </p:sp>
+      <p:sp>
+        <p:nvSpPr>
+          <p:cNvPr id="8" name="Text 6"/>
+          <p:cNvSpPr/>
+          <p:nvPr/>
+        </p:nvSpPr>
+        <p:spPr>
+          <a:xfrm>
+            <a:off x="4754880" y="2926080"/>
+            <a:ext cx="3931920" cy="320040"/>
+          </a:xfrm>
+          <a:prstGeom prst="rect">
+            <a:avLst/>
+          </a:prstGeom>
+          <a:noFill/>
+          <a:ln/>
+        </p:spPr>
+        <p:txBody>
+          <a:bodyPr wrap="square" rtlCol="0" anchor="ctr"/>
+          <a:lstStyle/>
+          <a:p>
+            <a:pPr algn="ctr" indent="0" marL="0">
+              <a:buNone/>
+            </a:pPr>
+            <a:r>
+              <a:rPr lang="en-US" sz="1400" b="1" dirty="0">
+                <a:solidFill>
+                  <a:srgbClr val="00D9FF"/>
+                </a:solidFill>
+                <a:latin typeface="Calibri" pitchFamily="34" charset="0"/>
+                <a:ea typeface="Calibri" pitchFamily="34" charset="-122"/>
+                <a:cs typeface="Calibri" pitchFamily="34" charset="-120"/>
+              </a:rPr>
+              <a:t>Scan to Visit Repository</a:t>
+            </a:r>
+            <a:endParaRPr lang="en-US" sz="1400" dirty="0"/>
+          </a:p>
+        </p:txBody>
+      </p:sp>
+      <p:pic>
+        <p:nvPicPr>
+          <p:cNvPr id="9" name="Image 0" descr="preencoded.png">    </p:cNvPr>
+          <p:cNvPicPr>
+            <a:picLocks noChangeAspect="1"/>
+          </p:cNvPicPr>
+          <p:nvPr/>
+        </p:nvPicPr>
+        <p:blipFill>
+          <a:blip r:embed="rId1"/>
+          <a:stretch>
+            <a:fillRect/>
+          </a:stretch>
+        </p:blipFill>
+        <p:spPr>
+          <a:xfrm>
+            <a:off x="5120640" y="3291840"/>
+            <a:ext cx="3200400" cy="3200400"/>
+          </a:xfrm>
+          <a:prstGeom prst="rect">
+            <a:avLst/>
+          </a:prstGeom>
+        </p:spPr>
+      </p:pic>
     </p:spTree>
   </p:cSld>
   <p:clrMapOvr>

</xml_diff>